<commit_message>
feat: expand template layout patterns for RM-038 (#238)
* docs(todo): add rm038 template pattern todo

* docs(todo): record rm038 branch setup

* docs(roadmap): track rm038 todo kickoff

* feat(templates): add rm038 layout patterns

* chore(todo): sync todo files → issues [skip md->issues]

* feat: integrate draft intelligence PoC (#235)

* docs(todo): add rm-036 kickoff todo

* chore(todo): sync todo files → issues [skip md->issues]

* feat(draft): add draft intelligence poc pipeline

* chore(todo): auto-complete PR #235

* chore(samples): add layout jsonl sample

---------

Co-authored-by: github-actions[bot] <41898282+github-actions[bot]@users.noreply.github.com>

* docs: document new layout patterns

* docs(todo): log rm038 progress

* chore(todo): sync todo files → issues [skip md->issues]

* docs(todo): close rm038 requirements check

* chore(todo): auto-complete PR #238

---------

Co-authored-by: github-actions[bot] <41898282+github-actions[bot]@users.noreply.github.com>
</commit_message>
<xml_diff>
--- a/samples/templates/templates.pptx
+++ b/samples/templates/templates.pptx
@@ -2979,6 +2979,1317 @@
 </p:sldLayout>
 </file>
 
+<file path=ppt/slideLayouts/slideLayout7.xml><?xml version="1.0" encoding="utf-8"?>
+<p:sldLayout xmlns:a="http://schemas.openxmlformats.org/drawingml/2006/main" xmlns:r="http://schemas.openxmlformats.org/officeDocument/2006/relationships" xmlns:p="http://schemas.openxmlformats.org/presentationml/2006/main" preserve="1" userDrawn="1">
+  <p:cSld name="Timeline Detail">
+    <p:spTree>
+      <p:nvGrpSpPr>
+        <p:cNvPr id="1" name=""/>
+        <p:cNvGrpSpPr/>
+        <p:nvPr/>
+      </p:nvGrpSpPr>
+      <p:grpSpPr>
+        <a:xfrm>
+          <a:off x="0" y="0"/>
+          <a:ext cx="0" cy="0"/>
+          <a:chOff x="0" y="0"/>
+          <a:chExt cx="0" cy="0"/>
+        </a:xfrm>
+      </p:grpSpPr>
+      <p:sp>
+        <p:nvSpPr>
+          <p:cNvPr id="2" name="タイトル 1">
+            <a:extLst>
+              <a:ext uri="{FF2B5EF4-FFF2-40B4-BE49-F238E27FC236}">
+                <a16:creationId xmlns:a16="http://schemas.microsoft.com/office/drawing/2014/main" id="{1C878911-0E99-4C7F-A17C-E4C6E06AD3EB}"/>
+              </a:ext>
+            </a:extLst>
+          </p:cNvPr>
+          <p:cNvSpPr>
+            <a:spLocks noGrp="1"/>
+          </p:cNvSpPr>
+          <p:nvPr>
+            <p:ph type="title"/>
+          </p:nvPr>
+        </p:nvSpPr>
+        <p:spPr/>
+        <p:txBody>
+          <a:bodyPr/>
+          <a:lstStyle>
+            <a:lvl1pPr>
+              <a:defRPr>
+                <a:latin typeface="Meiryo UI" panose="020B0604030504040204" pitchFamily="34" charset="-128"/>
+                <a:ea typeface="Meiryo UI" panose="020B0604030504040204" pitchFamily="34" charset="-128"/>
+              </a:defRPr>
+            </a:lvl1pPr>
+          </a:lstStyle>
+          <a:p>
+            <a:r>
+              <a:rPr kumimoji="1" lang="ja-JP" altLang="en-US"/>
+              <a:t>マスター タイトルの書式設定</a:t>
+            </a:r>
+          </a:p>
+        </p:txBody>
+      </p:sp>
+      <p:sp>
+        <p:nvSpPr>
+          <p:cNvPr id="3" name="Timeline Track">
+            <a:extLst>
+              <a:ext uri="{FF2B5EF4-FFF2-40B4-BE49-F238E27FC236}">
+                <a16:creationId xmlns:a16="http://schemas.microsoft.com/office/drawing/2014/main" id="{CE3F0D44-172A-CF1D-E1C1-730B2FD3226F}"/>
+              </a:ext>
+            </a:extLst>
+          </p:cNvPr>
+          <p:cNvSpPr>
+            <a:spLocks noGrp="1"/>
+          </p:cNvSpPr>
+          <p:nvPr>
+            <p:ph idx="1"/>
+          </p:nvPr>
+        </p:nvSpPr>
+        <p:spPr>
+          <a:xfrm>
+            <a:off x="312420" y="1591294"/>
+            <a:ext cx="5653374" cy="4585669"/>
+          </a:xfrm>
+        </p:spPr>
+        <p:txBody>
+          <a:bodyPr>
+            <a:normAutofit/>
+          </a:bodyPr>
+          <a:lstStyle>
+            <a:lvl1pPr>
+              <a:defRPr sz="1800">
+                <a:latin typeface="Meiryo UI" panose="020B0604030504040204" pitchFamily="34" charset="-128"/>
+                <a:ea typeface="Meiryo UI" panose="020B0604030504040204" pitchFamily="34" charset="-128"/>
+              </a:defRPr>
+            </a:lvl1pPr>
+            <a:lvl2pPr>
+              <a:defRPr sz="1600">
+                <a:latin typeface="Meiryo UI" panose="020B0604030504040204" pitchFamily="34" charset="-128"/>
+                <a:ea typeface="Meiryo UI" panose="020B0604030504040204" pitchFamily="34" charset="-128"/>
+              </a:defRPr>
+            </a:lvl2pPr>
+            <a:lvl3pPr>
+              <a:defRPr sz="1400">
+                <a:latin typeface="Meiryo UI" panose="020B0604030504040204" pitchFamily="34" charset="-128"/>
+                <a:ea typeface="Meiryo UI" panose="020B0604030504040204" pitchFamily="34" charset="-128"/>
+              </a:defRPr>
+            </a:lvl3pPr>
+            <a:lvl4pPr>
+              <a:defRPr sz="1200">
+                <a:latin typeface="Meiryo UI" panose="020B0604030504040204" pitchFamily="34" charset="-128"/>
+                <a:ea typeface="Meiryo UI" panose="020B0604030504040204" pitchFamily="34" charset="-128"/>
+              </a:defRPr>
+            </a:lvl4pPr>
+            <a:lvl5pPr>
+              <a:defRPr sz="1200">
+                <a:latin typeface="Meiryo UI" panose="020B0604030504040204" pitchFamily="34" charset="-128"/>
+                <a:ea typeface="Meiryo UI" panose="020B0604030504040204" pitchFamily="34" charset="-128"/>
+              </a:defRPr>
+            </a:lvl5pPr>
+          </a:lstStyle>
+          <a:p>
+            <a:pPr lvl="0"/>
+            <a:r>
+              <a:rPr kumimoji="1" lang="ja-JP" altLang="en-US"/>
+              <a:t>マスター テキストの書式設定</a:t>
+            </a:r>
+          </a:p>
+          <a:p>
+            <a:pPr lvl="1"/>
+            <a:r>
+              <a:rPr kumimoji="1" lang="ja-JP" altLang="en-US"/>
+              <a:t>第 </a:t>
+            </a:r>
+            <a:r>
+              <a:rPr kumimoji="1" lang="en-US" altLang="ja-JP"/>
+              <a:t>2 </a:t>
+            </a:r>
+            <a:r>
+              <a:rPr kumimoji="1" lang="ja-JP" altLang="en-US"/>
+              <a:t>レベル</a:t>
+            </a:r>
+          </a:p>
+          <a:p>
+            <a:pPr lvl="2"/>
+            <a:r>
+              <a:rPr kumimoji="1" lang="ja-JP" altLang="en-US"/>
+              <a:t>第 </a:t>
+            </a:r>
+            <a:r>
+              <a:rPr kumimoji="1" lang="en-US" altLang="ja-JP"/>
+              <a:t>3 </a:t>
+            </a:r>
+            <a:r>
+              <a:rPr kumimoji="1" lang="ja-JP" altLang="en-US"/>
+              <a:t>レベル</a:t>
+            </a:r>
+          </a:p>
+          <a:p>
+            <a:pPr lvl="3"/>
+            <a:r>
+              <a:rPr kumimoji="1" lang="ja-JP" altLang="en-US"/>
+              <a:t>第 </a:t>
+            </a:r>
+            <a:r>
+              <a:rPr kumimoji="1" lang="en-US" altLang="ja-JP"/>
+              <a:t>4 </a:t>
+            </a:r>
+            <a:r>
+              <a:rPr kumimoji="1" lang="ja-JP" altLang="en-US"/>
+              <a:t>レベル</a:t>
+            </a:r>
+          </a:p>
+          <a:p>
+            <a:pPr lvl="4"/>
+            <a:r>
+              <a:rPr kumimoji="1" lang="ja-JP" altLang="en-US"/>
+              <a:t>第 </a:t>
+            </a:r>
+            <a:r>
+              <a:rPr kumimoji="1" lang="en-US" altLang="ja-JP"/>
+              <a:t>5 </a:t>
+            </a:r>
+            <a:r>
+              <a:rPr kumimoji="1" lang="ja-JP" altLang="en-US"/>
+              <a:t>レベル</a:t>
+            </a:r>
+          </a:p>
+        </p:txBody>
+      </p:sp>
+      <p:sp>
+        <p:nvSpPr>
+          <p:cNvPr id="6" name="スライド番号プレースホルダー 5">
+            <a:extLst>
+              <a:ext uri="{FF2B5EF4-FFF2-40B4-BE49-F238E27FC236}">
+                <a16:creationId xmlns:a16="http://schemas.microsoft.com/office/drawing/2014/main" id="{ED36DFD0-93B2-8751-F203-50EE02E97C4C}"/>
+              </a:ext>
+            </a:extLst>
+          </p:cNvPr>
+          <p:cNvSpPr>
+            <a:spLocks noGrp="1"/>
+          </p:cNvSpPr>
+          <p:nvPr>
+            <p:ph type="sldNum" sz="quarter" idx="12"/>
+          </p:nvPr>
+        </p:nvSpPr>
+        <p:spPr/>
+        <p:txBody>
+          <a:bodyPr/>
+          <a:lstStyle>
+            <a:lvl1pPr>
+              <a:defRPr>
+                <a:latin typeface="Meiryo UI" panose="020B0604030504040204" pitchFamily="34" charset="-128"/>
+                <a:ea typeface="Meiryo UI" panose="020B0604030504040204" pitchFamily="34" charset="-128"/>
+              </a:defRPr>
+            </a:lvl1pPr>
+          </a:lstStyle>
+          <a:p>
+            <a:fld id="{C9FB15DA-11C7-0141-B5F8-718388A4C1CD}" type="slidenum">
+              <a:rPr lang="ja-JP" altLang="en-US" smtClean="0"/>
+              <a:pPr/>
+              <a:t>‹#›</a:t>
+            </a:fld>
+            <a:endParaRPr lang="ja-JP" altLang="en-US"/>
+          </a:p>
+        </p:txBody>
+      </p:sp>
+      <p:sp>
+        <p:nvSpPr>
+          <p:cNvPr id="4" name="Timeline Notes">
+            <a:extLst>
+              <a:ext uri="{FF2B5EF4-FFF2-40B4-BE49-F238E27FC236}">
+                <a16:creationId xmlns:a16="http://schemas.microsoft.com/office/drawing/2014/main" id="{F8E60AB5-72BD-C2E5-C767-BC6D3DD300C1}"/>
+              </a:ext>
+            </a:extLst>
+          </p:cNvPr>
+          <p:cNvSpPr>
+            <a:spLocks noGrp="1"/>
+          </p:cNvSpPr>
+          <p:nvPr>
+            <p:ph idx="14"/>
+          </p:nvPr>
+        </p:nvSpPr>
+        <p:spPr>
+          <a:xfrm>
+            <a:off x="6226206" y="1591293"/>
+            <a:ext cx="5653374" cy="4585669"/>
+          </a:xfrm>
+        </p:spPr>
+        <p:txBody>
+          <a:bodyPr>
+            <a:normAutofit/>
+          </a:bodyPr>
+          <a:lstStyle>
+            <a:lvl1pPr>
+              <a:defRPr sz="1800">
+                <a:latin typeface="Meiryo UI" panose="020B0604030504040204" pitchFamily="34" charset="-128"/>
+                <a:ea typeface="Meiryo UI" panose="020B0604030504040204" pitchFamily="34" charset="-128"/>
+              </a:defRPr>
+            </a:lvl1pPr>
+            <a:lvl2pPr>
+              <a:defRPr sz="1600">
+                <a:latin typeface="Meiryo UI" panose="020B0604030504040204" pitchFamily="34" charset="-128"/>
+                <a:ea typeface="Meiryo UI" panose="020B0604030504040204" pitchFamily="34" charset="-128"/>
+              </a:defRPr>
+            </a:lvl2pPr>
+            <a:lvl3pPr>
+              <a:defRPr sz="1400">
+                <a:latin typeface="Meiryo UI" panose="020B0604030504040204" pitchFamily="34" charset="-128"/>
+                <a:ea typeface="Meiryo UI" panose="020B0604030504040204" pitchFamily="34" charset="-128"/>
+              </a:defRPr>
+            </a:lvl3pPr>
+            <a:lvl4pPr>
+              <a:defRPr sz="1200">
+                <a:latin typeface="Meiryo UI" panose="020B0604030504040204" pitchFamily="34" charset="-128"/>
+                <a:ea typeface="Meiryo UI" panose="020B0604030504040204" pitchFamily="34" charset="-128"/>
+              </a:defRPr>
+            </a:lvl4pPr>
+            <a:lvl5pPr>
+              <a:defRPr sz="1200">
+                <a:latin typeface="Meiryo UI" panose="020B0604030504040204" pitchFamily="34" charset="-128"/>
+                <a:ea typeface="Meiryo UI" panose="020B0604030504040204" pitchFamily="34" charset="-128"/>
+              </a:defRPr>
+            </a:lvl5pPr>
+          </a:lstStyle>
+          <a:p>
+            <a:pPr lvl="0"/>
+            <a:r>
+              <a:rPr kumimoji="1" lang="ja-JP" altLang="en-US"/>
+              <a:t>マスター テキストの書式設定</a:t>
+            </a:r>
+          </a:p>
+          <a:p>
+            <a:pPr lvl="1"/>
+            <a:r>
+              <a:rPr kumimoji="1" lang="ja-JP" altLang="en-US"/>
+              <a:t>第 </a:t>
+            </a:r>
+            <a:r>
+              <a:rPr kumimoji="1" lang="en-US" altLang="ja-JP"/>
+              <a:t>2 </a:t>
+            </a:r>
+            <a:r>
+              <a:rPr kumimoji="1" lang="ja-JP" altLang="en-US"/>
+              <a:t>レベル</a:t>
+            </a:r>
+          </a:p>
+          <a:p>
+            <a:pPr lvl="2"/>
+            <a:r>
+              <a:rPr kumimoji="1" lang="ja-JP" altLang="en-US"/>
+              <a:t>第 </a:t>
+            </a:r>
+            <a:r>
+              <a:rPr kumimoji="1" lang="en-US" altLang="ja-JP"/>
+              <a:t>3 </a:t>
+            </a:r>
+            <a:r>
+              <a:rPr kumimoji="1" lang="ja-JP" altLang="en-US"/>
+              <a:t>レベル</a:t>
+            </a:r>
+          </a:p>
+          <a:p>
+            <a:pPr lvl="3"/>
+            <a:r>
+              <a:rPr kumimoji="1" lang="ja-JP" altLang="en-US"/>
+              <a:t>第 </a:t>
+            </a:r>
+            <a:r>
+              <a:rPr kumimoji="1" lang="en-US" altLang="ja-JP"/>
+              <a:t>4 </a:t>
+            </a:r>
+            <a:r>
+              <a:rPr kumimoji="1" lang="ja-JP" altLang="en-US"/>
+              <a:t>レベル</a:t>
+            </a:r>
+          </a:p>
+          <a:p>
+            <a:pPr lvl="4"/>
+            <a:r>
+              <a:rPr kumimoji="1" lang="ja-JP" altLang="en-US"/>
+              <a:t>第 </a:t>
+            </a:r>
+            <a:r>
+              <a:rPr kumimoji="1" lang="en-US" altLang="ja-JP"/>
+              <a:t>5 </a:t>
+            </a:r>
+            <a:r>
+              <a:rPr kumimoji="1" lang="ja-JP" altLang="en-US"/>
+              <a:t>レベル</a:t>
+            </a:r>
+          </a:p>
+        </p:txBody>
+      </p:sp>
+      <p:sp>
+        <p:nvSpPr>
+          <p:cNvPr id="7" name="Timeline Subtitle">
+            <a:extLst>
+              <a:ext uri="{FF2B5EF4-FFF2-40B4-BE49-F238E27FC236}">
+                <a16:creationId xmlns:a16="http://schemas.microsoft.com/office/drawing/2014/main" id="{1637E228-8434-900D-0254-AF837975524B}"/>
+              </a:ext>
+            </a:extLst>
+          </p:cNvPr>
+          <p:cNvSpPr>
+            <a:spLocks noGrp="1"/>
+          </p:cNvSpPr>
+          <p:nvPr>
+            <p:ph type="subTitle" idx="15" hasCustomPrompt="1"/>
+          </p:nvPr>
+        </p:nvSpPr>
+        <p:spPr>
+          <a:xfrm>
+            <a:off x="312420" y="0"/>
+            <a:ext cx="4694586" cy="320634"/>
+          </a:xfrm>
+        </p:spPr>
+        <p:txBody>
+          <a:bodyPr anchor="b">
+            <a:normAutofit/>
+          </a:bodyPr>
+          <a:lstStyle>
+            <a:lvl1pPr marL="0" indent="0" algn="l">
+              <a:buNone/>
+              <a:defRPr sz="1800">
+                <a:solidFill>
+                  <a:srgbClr val="767676"/>
+                </a:solidFill>
+              </a:defRPr>
+            </a:lvl1pPr>
+            <a:lvl2pPr marL="457200" indent="0" algn="ctr">
+              <a:buNone/>
+              <a:defRPr sz="2000"/>
+            </a:lvl2pPr>
+            <a:lvl3pPr marL="914400" indent="0" algn="ctr">
+              <a:buNone/>
+              <a:defRPr sz="1800"/>
+            </a:lvl3pPr>
+            <a:lvl4pPr marL="1371600" indent="0" algn="ctr">
+              <a:buNone/>
+              <a:defRPr sz="1600"/>
+            </a:lvl4pPr>
+            <a:lvl5pPr marL="1828800" indent="0" algn="ctr">
+              <a:buNone/>
+              <a:defRPr sz="1600"/>
+            </a:lvl5pPr>
+            <a:lvl6pPr marL="2286000" indent="0" algn="ctr">
+              <a:buNone/>
+              <a:defRPr sz="1600"/>
+            </a:lvl6pPr>
+            <a:lvl7pPr marL="2743200" indent="0" algn="ctr">
+              <a:buNone/>
+              <a:defRPr sz="1600"/>
+            </a:lvl7pPr>
+            <a:lvl8pPr marL="3200400" indent="0" algn="ctr">
+              <a:buNone/>
+              <a:defRPr sz="1600"/>
+            </a:lvl8pPr>
+            <a:lvl9pPr marL="3657600" indent="0" algn="ctr">
+              <a:buNone/>
+              <a:defRPr sz="1600"/>
+            </a:lvl9pPr>
+          </a:lstStyle>
+          <a:p>
+            <a:pPr lvl="0"/>
+            <a:r>
+              <a:rPr kumimoji="1" lang="ja-JP" altLang="en-US"/>
+              <a:t>サブタイトル</a:t>
+            </a:r>
+            <a:r>
+              <a:rPr kumimoji="1" lang="en-US" altLang="ja-JP" dirty="0"/>
+              <a:t> </a:t>
+            </a:r>
+            <a:r>
+              <a:rPr kumimoji="1" lang="ja-JP" altLang="en-US"/>
+              <a:t>の書式設定</a:t>
+            </a:r>
+          </a:p>
+        </p:txBody>
+      </p:sp>
+      <p:sp>
+        <p:nvSpPr>
+          <p:cNvPr id="5" name="Logo">
+            <a:extLst>
+              <a:ext uri="{FF2B5EF4-FFF2-40B4-BE49-F238E27FC236}">
+                <a16:creationId xmlns:a16="http://schemas.microsoft.com/office/drawing/2014/main" id="{4E369FD4-93A8-E2C2-D23D-495B39C171AF}"/>
+              </a:ext>
+            </a:extLst>
+          </p:cNvPr>
+          <p:cNvSpPr>
+            <a:spLocks noGrp="1"/>
+          </p:cNvSpPr>
+          <p:nvPr>
+            <p:ph sz="quarter" idx="16" hasCustomPrompt="1"/>
+          </p:nvPr>
+        </p:nvSpPr>
+        <p:spPr>
+          <a:xfrm>
+            <a:off x="10965176" y="5262563"/>
+            <a:ext cx="914400" cy="914400"/>
+          </a:xfrm>
+        </p:spPr>
+        <p:txBody>
+          <a:bodyPr/>
+          <a:lstStyle>
+            <a:lvl1pPr marL="0" indent="0">
+              <a:buNone/>
+              <a:defRPr/>
+            </a:lvl1pPr>
+          </a:lstStyle>
+          <a:p>
+            <a:pPr lvl="0"/>
+            <a:r>
+              <a:rPr kumimoji="1" lang="en-US" altLang="ja-JP" dirty="0"/>
+              <a:t>logo</a:t>
+            </a:r>
+            <a:endParaRPr kumimoji="1" lang="ja-JP" altLang="en-US"/>
+          </a:p>
+        </p:txBody>
+      </p:sp>
+    </p:spTree>
+    <p:extLst>
+      <p:ext uri="{BB962C8B-B14F-4D97-AF65-F5344CB8AC3E}">
+        <p14:creationId xmlns:p14="http://schemas.microsoft.com/office/powerpoint/2010/main" val="3761077251"/>
+      </p:ext>
+    </p:extLst>
+  </p:cSld>
+  <p:clrMapOvr>
+    <a:masterClrMapping/>
+  </p:clrMapOvr>
+</p:sldLayout>
+</file>
+
+<file path=ppt/slideLayouts/slideLayout8.xml><?xml version="1.0" encoding="utf-8"?>
+<p:sldLayout xmlns:a="http://schemas.openxmlformats.org/drawingml/2006/main" xmlns:r="http://schemas.openxmlformats.org/officeDocument/2006/relationships" xmlns:p="http://schemas.openxmlformats.org/presentationml/2006/main" preserve="1" userDrawn="1">
+  <p:cSld name="Comparison Two Axis">
+    <p:spTree>
+      <p:nvGrpSpPr>
+        <p:cNvPr id="1" name=""/>
+        <p:cNvGrpSpPr/>
+        <p:nvPr/>
+      </p:nvGrpSpPr>
+      <p:grpSpPr>
+        <a:xfrm>
+          <a:off x="0" y="0"/>
+          <a:ext cx="0" cy="0"/>
+          <a:chOff x="0" y="0"/>
+          <a:chExt cx="0" cy="0"/>
+        </a:xfrm>
+      </p:grpSpPr>
+      <p:sp>
+        <p:nvSpPr>
+          <p:cNvPr id="2" name="タイトル 1">
+            <a:extLst>
+              <a:ext uri="{FF2B5EF4-FFF2-40B4-BE49-F238E27FC236}">
+                <a16:creationId xmlns:a16="http://schemas.microsoft.com/office/drawing/2014/main" id="{1C878911-0E99-4C7F-A17C-E4C6E06AD3EB}"/>
+              </a:ext>
+            </a:extLst>
+          </p:cNvPr>
+          <p:cNvSpPr>
+            <a:spLocks noGrp="1"/>
+          </p:cNvSpPr>
+          <p:nvPr>
+            <p:ph type="title"/>
+          </p:nvPr>
+        </p:nvSpPr>
+        <p:spPr/>
+        <p:txBody>
+          <a:bodyPr/>
+          <a:lstStyle>
+            <a:lvl1pPr>
+              <a:defRPr>
+                <a:latin typeface="Meiryo UI" panose="020B0604030504040204" pitchFamily="34" charset="-128"/>
+                <a:ea typeface="Meiryo UI" panose="020B0604030504040204" pitchFamily="34" charset="-128"/>
+              </a:defRPr>
+            </a:lvl1pPr>
+          </a:lstStyle>
+          <a:p>
+            <a:r>
+              <a:rPr kumimoji="1" lang="ja-JP" altLang="en-US"/>
+              <a:t>マスター タイトルの書式設定</a:t>
+            </a:r>
+          </a:p>
+        </p:txBody>
+      </p:sp>
+      <p:sp>
+        <p:nvSpPr>
+          <p:cNvPr id="3" name="Axis Left">
+            <a:extLst>
+              <a:ext uri="{FF2B5EF4-FFF2-40B4-BE49-F238E27FC236}">
+                <a16:creationId xmlns:a16="http://schemas.microsoft.com/office/drawing/2014/main" id="{CE3F0D44-172A-CF1D-E1C1-730B2FD3226F}"/>
+              </a:ext>
+            </a:extLst>
+          </p:cNvPr>
+          <p:cNvSpPr>
+            <a:spLocks noGrp="1"/>
+          </p:cNvSpPr>
+          <p:nvPr>
+            <p:ph idx="1"/>
+          </p:nvPr>
+        </p:nvSpPr>
+        <p:spPr>
+          <a:xfrm>
+            <a:off x="312420" y="1591294"/>
+            <a:ext cx="5653374" cy="4585669"/>
+          </a:xfrm>
+        </p:spPr>
+        <p:txBody>
+          <a:bodyPr>
+            <a:normAutofit/>
+          </a:bodyPr>
+          <a:lstStyle>
+            <a:lvl1pPr>
+              <a:defRPr sz="1800">
+                <a:latin typeface="Meiryo UI" panose="020B0604030504040204" pitchFamily="34" charset="-128"/>
+                <a:ea typeface="Meiryo UI" panose="020B0604030504040204" pitchFamily="34" charset="-128"/>
+              </a:defRPr>
+            </a:lvl1pPr>
+            <a:lvl2pPr>
+              <a:defRPr sz="1600">
+                <a:latin typeface="Meiryo UI" panose="020B0604030504040204" pitchFamily="34" charset="-128"/>
+                <a:ea typeface="Meiryo UI" panose="020B0604030504040204" pitchFamily="34" charset="-128"/>
+              </a:defRPr>
+            </a:lvl2pPr>
+            <a:lvl3pPr>
+              <a:defRPr sz="1400">
+                <a:latin typeface="Meiryo UI" panose="020B0604030504040204" pitchFamily="34" charset="-128"/>
+                <a:ea typeface="Meiryo UI" panose="020B0604030504040204" pitchFamily="34" charset="-128"/>
+              </a:defRPr>
+            </a:lvl3pPr>
+            <a:lvl4pPr>
+              <a:defRPr sz="1200">
+                <a:latin typeface="Meiryo UI" panose="020B0604030504040204" pitchFamily="34" charset="-128"/>
+                <a:ea typeface="Meiryo UI" panose="020B0604030504040204" pitchFamily="34" charset="-128"/>
+              </a:defRPr>
+            </a:lvl4pPr>
+            <a:lvl5pPr>
+              <a:defRPr sz="1200">
+                <a:latin typeface="Meiryo UI" panose="020B0604030504040204" pitchFamily="34" charset="-128"/>
+                <a:ea typeface="Meiryo UI" panose="020B0604030504040204" pitchFamily="34" charset="-128"/>
+              </a:defRPr>
+            </a:lvl5pPr>
+          </a:lstStyle>
+          <a:p>
+            <a:pPr lvl="0"/>
+            <a:r>
+              <a:rPr kumimoji="1" lang="ja-JP" altLang="en-US"/>
+              <a:t>マスター テキストの書式設定</a:t>
+            </a:r>
+          </a:p>
+          <a:p>
+            <a:pPr lvl="1"/>
+            <a:r>
+              <a:rPr kumimoji="1" lang="ja-JP" altLang="en-US"/>
+              <a:t>第 </a:t>
+            </a:r>
+            <a:r>
+              <a:rPr kumimoji="1" lang="en-US" altLang="ja-JP"/>
+              <a:t>2 </a:t>
+            </a:r>
+            <a:r>
+              <a:rPr kumimoji="1" lang="ja-JP" altLang="en-US"/>
+              <a:t>レベル</a:t>
+            </a:r>
+          </a:p>
+          <a:p>
+            <a:pPr lvl="2"/>
+            <a:r>
+              <a:rPr kumimoji="1" lang="ja-JP" altLang="en-US"/>
+              <a:t>第 </a:t>
+            </a:r>
+            <a:r>
+              <a:rPr kumimoji="1" lang="en-US" altLang="ja-JP"/>
+              <a:t>3 </a:t>
+            </a:r>
+            <a:r>
+              <a:rPr kumimoji="1" lang="ja-JP" altLang="en-US"/>
+              <a:t>レベル</a:t>
+            </a:r>
+          </a:p>
+          <a:p>
+            <a:pPr lvl="3"/>
+            <a:r>
+              <a:rPr kumimoji="1" lang="ja-JP" altLang="en-US"/>
+              <a:t>第 </a:t>
+            </a:r>
+            <a:r>
+              <a:rPr kumimoji="1" lang="en-US" altLang="ja-JP"/>
+              <a:t>4 </a:t>
+            </a:r>
+            <a:r>
+              <a:rPr kumimoji="1" lang="ja-JP" altLang="en-US"/>
+              <a:t>レベル</a:t>
+            </a:r>
+          </a:p>
+          <a:p>
+            <a:pPr lvl="4"/>
+            <a:r>
+              <a:rPr kumimoji="1" lang="ja-JP" altLang="en-US"/>
+              <a:t>第 </a:t>
+            </a:r>
+            <a:r>
+              <a:rPr kumimoji="1" lang="en-US" altLang="ja-JP"/>
+              <a:t>5 </a:t>
+            </a:r>
+            <a:r>
+              <a:rPr kumimoji="1" lang="ja-JP" altLang="en-US"/>
+              <a:t>レベル</a:t>
+            </a:r>
+          </a:p>
+        </p:txBody>
+      </p:sp>
+      <p:sp>
+        <p:nvSpPr>
+          <p:cNvPr id="6" name="スライド番号プレースホルダー 5">
+            <a:extLst>
+              <a:ext uri="{FF2B5EF4-FFF2-40B4-BE49-F238E27FC236}">
+                <a16:creationId xmlns:a16="http://schemas.microsoft.com/office/drawing/2014/main" id="{ED36DFD0-93B2-8751-F203-50EE02E97C4C}"/>
+              </a:ext>
+            </a:extLst>
+          </p:cNvPr>
+          <p:cNvSpPr>
+            <a:spLocks noGrp="1"/>
+          </p:cNvSpPr>
+          <p:nvPr>
+            <p:ph type="sldNum" sz="quarter" idx="12"/>
+          </p:nvPr>
+        </p:nvSpPr>
+        <p:spPr/>
+        <p:txBody>
+          <a:bodyPr/>
+          <a:lstStyle>
+            <a:lvl1pPr>
+              <a:defRPr>
+                <a:latin typeface="Meiryo UI" panose="020B0604030504040204" pitchFamily="34" charset="-128"/>
+                <a:ea typeface="Meiryo UI" panose="020B0604030504040204" pitchFamily="34" charset="-128"/>
+              </a:defRPr>
+            </a:lvl1pPr>
+          </a:lstStyle>
+          <a:p>
+            <a:fld id="{C9FB15DA-11C7-0141-B5F8-718388A4C1CD}" type="slidenum">
+              <a:rPr lang="ja-JP" altLang="en-US" smtClean="0"/>
+              <a:pPr/>
+              <a:t>‹#›</a:t>
+            </a:fld>
+            <a:endParaRPr lang="ja-JP" altLang="en-US"/>
+          </a:p>
+        </p:txBody>
+      </p:sp>
+      <p:sp>
+        <p:nvSpPr>
+          <p:cNvPr id="4" name="Axis Right">
+            <a:extLst>
+              <a:ext uri="{FF2B5EF4-FFF2-40B4-BE49-F238E27FC236}">
+                <a16:creationId xmlns:a16="http://schemas.microsoft.com/office/drawing/2014/main" id="{F8E60AB5-72BD-C2E5-C767-BC6D3DD300C1}"/>
+              </a:ext>
+            </a:extLst>
+          </p:cNvPr>
+          <p:cNvSpPr>
+            <a:spLocks noGrp="1"/>
+          </p:cNvSpPr>
+          <p:nvPr>
+            <p:ph idx="14"/>
+          </p:nvPr>
+        </p:nvSpPr>
+        <p:spPr>
+          <a:xfrm>
+            <a:off x="6226206" y="1591293"/>
+            <a:ext cx="5653374" cy="4585669"/>
+          </a:xfrm>
+        </p:spPr>
+        <p:txBody>
+          <a:bodyPr>
+            <a:normAutofit/>
+          </a:bodyPr>
+          <a:lstStyle>
+            <a:lvl1pPr>
+              <a:defRPr sz="1800">
+                <a:latin typeface="Meiryo UI" panose="020B0604030504040204" pitchFamily="34" charset="-128"/>
+                <a:ea typeface="Meiryo UI" panose="020B0604030504040204" pitchFamily="34" charset="-128"/>
+              </a:defRPr>
+            </a:lvl1pPr>
+            <a:lvl2pPr>
+              <a:defRPr sz="1600">
+                <a:latin typeface="Meiryo UI" panose="020B0604030504040204" pitchFamily="34" charset="-128"/>
+                <a:ea typeface="Meiryo UI" panose="020B0604030504040204" pitchFamily="34" charset="-128"/>
+              </a:defRPr>
+            </a:lvl2pPr>
+            <a:lvl3pPr>
+              <a:defRPr sz="1400">
+                <a:latin typeface="Meiryo UI" panose="020B0604030504040204" pitchFamily="34" charset="-128"/>
+                <a:ea typeface="Meiryo UI" panose="020B0604030504040204" pitchFamily="34" charset="-128"/>
+              </a:defRPr>
+            </a:lvl3pPr>
+            <a:lvl4pPr>
+              <a:defRPr sz="1200">
+                <a:latin typeface="Meiryo UI" panose="020B0604030504040204" pitchFamily="34" charset="-128"/>
+                <a:ea typeface="Meiryo UI" panose="020B0604030504040204" pitchFamily="34" charset="-128"/>
+              </a:defRPr>
+            </a:lvl4pPr>
+            <a:lvl5pPr>
+              <a:defRPr sz="1200">
+                <a:latin typeface="Meiryo UI" panose="020B0604030504040204" pitchFamily="34" charset="-128"/>
+                <a:ea typeface="Meiryo UI" panose="020B0604030504040204" pitchFamily="34" charset="-128"/>
+              </a:defRPr>
+            </a:lvl5pPr>
+          </a:lstStyle>
+          <a:p>
+            <a:pPr lvl="0"/>
+            <a:r>
+              <a:rPr kumimoji="1" lang="ja-JP" altLang="en-US"/>
+              <a:t>マスター テキストの書式設定</a:t>
+            </a:r>
+          </a:p>
+          <a:p>
+            <a:pPr lvl="1"/>
+            <a:r>
+              <a:rPr kumimoji="1" lang="ja-JP" altLang="en-US"/>
+              <a:t>第 </a:t>
+            </a:r>
+            <a:r>
+              <a:rPr kumimoji="1" lang="en-US" altLang="ja-JP"/>
+              <a:t>2 </a:t>
+            </a:r>
+            <a:r>
+              <a:rPr kumimoji="1" lang="ja-JP" altLang="en-US"/>
+              <a:t>レベル</a:t>
+            </a:r>
+          </a:p>
+          <a:p>
+            <a:pPr lvl="2"/>
+            <a:r>
+              <a:rPr kumimoji="1" lang="ja-JP" altLang="en-US"/>
+              <a:t>第 </a:t>
+            </a:r>
+            <a:r>
+              <a:rPr kumimoji="1" lang="en-US" altLang="ja-JP"/>
+              <a:t>3 </a:t>
+            </a:r>
+            <a:r>
+              <a:rPr kumimoji="1" lang="ja-JP" altLang="en-US"/>
+              <a:t>レベル</a:t>
+            </a:r>
+          </a:p>
+          <a:p>
+            <a:pPr lvl="3"/>
+            <a:r>
+              <a:rPr kumimoji="1" lang="ja-JP" altLang="en-US"/>
+              <a:t>第 </a:t>
+            </a:r>
+            <a:r>
+              <a:rPr kumimoji="1" lang="en-US" altLang="ja-JP"/>
+              <a:t>4 </a:t>
+            </a:r>
+            <a:r>
+              <a:rPr kumimoji="1" lang="ja-JP" altLang="en-US"/>
+              <a:t>レベル</a:t>
+            </a:r>
+          </a:p>
+          <a:p>
+            <a:pPr lvl="4"/>
+            <a:r>
+              <a:rPr kumimoji="1" lang="ja-JP" altLang="en-US"/>
+              <a:t>第 </a:t>
+            </a:r>
+            <a:r>
+              <a:rPr kumimoji="1" lang="en-US" altLang="ja-JP"/>
+              <a:t>5 </a:t>
+            </a:r>
+            <a:r>
+              <a:rPr kumimoji="1" lang="ja-JP" altLang="en-US"/>
+              <a:t>レベル</a:t>
+            </a:r>
+          </a:p>
+        </p:txBody>
+      </p:sp>
+      <p:sp>
+        <p:nvSpPr>
+          <p:cNvPr id="7" name="Axis Subtitle">
+            <a:extLst>
+              <a:ext uri="{FF2B5EF4-FFF2-40B4-BE49-F238E27FC236}">
+                <a16:creationId xmlns:a16="http://schemas.microsoft.com/office/drawing/2014/main" id="{1637E228-8434-900D-0254-AF837975524B}"/>
+              </a:ext>
+            </a:extLst>
+          </p:cNvPr>
+          <p:cNvSpPr>
+            <a:spLocks noGrp="1"/>
+          </p:cNvSpPr>
+          <p:nvPr>
+            <p:ph type="subTitle" idx="15" hasCustomPrompt="1"/>
+          </p:nvPr>
+        </p:nvSpPr>
+        <p:spPr>
+          <a:xfrm>
+            <a:off x="312420" y="0"/>
+            <a:ext cx="4694586" cy="320634"/>
+          </a:xfrm>
+        </p:spPr>
+        <p:txBody>
+          <a:bodyPr anchor="b">
+            <a:normAutofit/>
+          </a:bodyPr>
+          <a:lstStyle>
+            <a:lvl1pPr marL="0" indent="0" algn="l">
+              <a:buNone/>
+              <a:defRPr sz="1800">
+                <a:solidFill>
+                  <a:srgbClr val="767676"/>
+                </a:solidFill>
+              </a:defRPr>
+            </a:lvl1pPr>
+            <a:lvl2pPr marL="457200" indent="0" algn="ctr">
+              <a:buNone/>
+              <a:defRPr sz="2000"/>
+            </a:lvl2pPr>
+            <a:lvl3pPr marL="914400" indent="0" algn="ctr">
+              <a:buNone/>
+              <a:defRPr sz="1800"/>
+            </a:lvl3pPr>
+            <a:lvl4pPr marL="1371600" indent="0" algn="ctr">
+              <a:buNone/>
+              <a:defRPr sz="1600"/>
+            </a:lvl4pPr>
+            <a:lvl5pPr marL="1828800" indent="0" algn="ctr">
+              <a:buNone/>
+              <a:defRPr sz="1600"/>
+            </a:lvl5pPr>
+            <a:lvl6pPr marL="2286000" indent="0" algn="ctr">
+              <a:buNone/>
+              <a:defRPr sz="1600"/>
+            </a:lvl6pPr>
+            <a:lvl7pPr marL="2743200" indent="0" algn="ctr">
+              <a:buNone/>
+              <a:defRPr sz="1600"/>
+            </a:lvl7pPr>
+            <a:lvl8pPr marL="3200400" indent="0" algn="ctr">
+              <a:buNone/>
+              <a:defRPr sz="1600"/>
+            </a:lvl8pPr>
+            <a:lvl9pPr marL="3657600" indent="0" algn="ctr">
+              <a:buNone/>
+              <a:defRPr sz="1600"/>
+            </a:lvl9pPr>
+          </a:lstStyle>
+          <a:p>
+            <a:pPr lvl="0"/>
+            <a:r>
+              <a:rPr kumimoji="1" lang="ja-JP" altLang="en-US"/>
+              <a:t>サブタイトル</a:t>
+            </a:r>
+            <a:r>
+              <a:rPr kumimoji="1" lang="en-US" altLang="ja-JP" dirty="0"/>
+              <a:t> </a:t>
+            </a:r>
+            <a:r>
+              <a:rPr kumimoji="1" lang="ja-JP" altLang="en-US"/>
+              <a:t>の書式設定</a:t>
+            </a:r>
+          </a:p>
+        </p:txBody>
+      </p:sp>
+      <p:sp>
+        <p:nvSpPr>
+          <p:cNvPr id="5" name="Logo">
+            <a:extLst>
+              <a:ext uri="{FF2B5EF4-FFF2-40B4-BE49-F238E27FC236}">
+                <a16:creationId xmlns:a16="http://schemas.microsoft.com/office/drawing/2014/main" id="{4E369FD4-93A8-E2C2-D23D-495B39C171AF}"/>
+              </a:ext>
+            </a:extLst>
+          </p:cNvPr>
+          <p:cNvSpPr>
+            <a:spLocks noGrp="1"/>
+          </p:cNvSpPr>
+          <p:nvPr>
+            <p:ph sz="quarter" idx="16" hasCustomPrompt="1"/>
+          </p:nvPr>
+        </p:nvSpPr>
+        <p:spPr>
+          <a:xfrm>
+            <a:off x="10965176" y="5262563"/>
+            <a:ext cx="914400" cy="914400"/>
+          </a:xfrm>
+        </p:spPr>
+        <p:txBody>
+          <a:bodyPr/>
+          <a:lstStyle>
+            <a:lvl1pPr marL="0" indent="0">
+              <a:buNone/>
+              <a:defRPr/>
+            </a:lvl1pPr>
+          </a:lstStyle>
+          <a:p>
+            <a:pPr lvl="0"/>
+            <a:r>
+              <a:rPr kumimoji="1" lang="en-US" altLang="ja-JP" dirty="0"/>
+              <a:t>logo</a:t>
+            </a:r>
+            <a:endParaRPr kumimoji="1" lang="ja-JP" altLang="en-US"/>
+          </a:p>
+        </p:txBody>
+      </p:sp>
+    </p:spTree>
+    <p:extLst>
+      <p:ext uri="{BB962C8B-B14F-4D97-AF65-F5344CB8AC3E}">
+        <p14:creationId xmlns:p14="http://schemas.microsoft.com/office/powerpoint/2010/main" val="3761077251"/>
+      </p:ext>
+    </p:extLst>
+  </p:cSld>
+  <p:clrMapOvr>
+    <a:masterClrMapping/>
+  </p:clrMapOvr>
+</p:sldLayout>
+</file>
+
+<file path=ppt/slideLayouts/slideLayout9.xml><?xml version="1.0" encoding="utf-8"?>
+<p:sldLayout xmlns:a="http://schemas.openxmlformats.org/drawingml/2006/main" xmlns:r="http://schemas.openxmlformats.org/officeDocument/2006/relationships" xmlns:p="http://schemas.openxmlformats.org/presentationml/2006/main" preserve="1" userDrawn="1">
+  <p:cSld name="Fact Sheet">
+    <p:spTree>
+      <p:nvGrpSpPr>
+        <p:cNvPr id="1" name=""/>
+        <p:cNvGrpSpPr/>
+        <p:nvPr/>
+      </p:nvGrpSpPr>
+      <p:grpSpPr>
+        <a:xfrm>
+          <a:off x="0" y="0"/>
+          <a:ext cx="0" cy="0"/>
+          <a:chOff x="0" y="0"/>
+          <a:chExt cx="0" cy="0"/>
+        </a:xfrm>
+      </p:grpSpPr>
+      <p:sp>
+        <p:nvSpPr>
+          <p:cNvPr id="2" name="タイトル 1">
+            <a:extLst>
+              <a:ext uri="{FF2B5EF4-FFF2-40B4-BE49-F238E27FC236}">
+                <a16:creationId xmlns:a16="http://schemas.microsoft.com/office/drawing/2014/main" id="{1C878911-0E99-4C7F-A17C-E4C6E06AD3EB}"/>
+              </a:ext>
+            </a:extLst>
+          </p:cNvPr>
+          <p:cNvSpPr>
+            <a:spLocks noGrp="1"/>
+          </p:cNvSpPr>
+          <p:nvPr>
+            <p:ph type="title"/>
+          </p:nvPr>
+        </p:nvSpPr>
+        <p:spPr/>
+        <p:txBody>
+          <a:bodyPr/>
+          <a:lstStyle>
+            <a:lvl1pPr>
+              <a:defRPr>
+                <a:latin typeface="Meiryo UI" panose="020B0604030504040204" pitchFamily="34" charset="-128"/>
+                <a:ea typeface="Meiryo UI" panose="020B0604030504040204" pitchFamily="34" charset="-128"/>
+              </a:defRPr>
+            </a:lvl1pPr>
+          </a:lstStyle>
+          <a:p>
+            <a:r>
+              <a:rPr kumimoji="1" lang="ja-JP" altLang="en-US"/>
+              <a:t>マスター タイトルの書式設定</a:t>
+            </a:r>
+          </a:p>
+        </p:txBody>
+      </p:sp>
+      <p:sp>
+        <p:nvSpPr>
+          <p:cNvPr id="3" name="Fact Summary">
+            <a:extLst>
+              <a:ext uri="{FF2B5EF4-FFF2-40B4-BE49-F238E27FC236}">
+                <a16:creationId xmlns:a16="http://schemas.microsoft.com/office/drawing/2014/main" id="{CE3F0D44-172A-CF1D-E1C1-730B2FD3226F}"/>
+              </a:ext>
+            </a:extLst>
+          </p:cNvPr>
+          <p:cNvSpPr>
+            <a:spLocks noGrp="1"/>
+          </p:cNvSpPr>
+          <p:nvPr>
+            <p:ph idx="1"/>
+          </p:nvPr>
+        </p:nvSpPr>
+        <p:spPr/>
+        <p:txBody>
+          <a:bodyPr>
+            <a:normAutofit/>
+          </a:bodyPr>
+          <a:lstStyle>
+            <a:lvl1pPr>
+              <a:defRPr sz="1800">
+                <a:latin typeface="Meiryo UI" panose="020B0604030504040204" pitchFamily="34" charset="-128"/>
+                <a:ea typeface="Meiryo UI" panose="020B0604030504040204" pitchFamily="34" charset="-128"/>
+              </a:defRPr>
+            </a:lvl1pPr>
+            <a:lvl2pPr>
+              <a:defRPr sz="1600">
+                <a:latin typeface="Meiryo UI" panose="020B0604030504040204" pitchFamily="34" charset="-128"/>
+                <a:ea typeface="Meiryo UI" panose="020B0604030504040204" pitchFamily="34" charset="-128"/>
+              </a:defRPr>
+            </a:lvl2pPr>
+            <a:lvl3pPr>
+              <a:defRPr sz="1400">
+                <a:latin typeface="Meiryo UI" panose="020B0604030504040204" pitchFamily="34" charset="-128"/>
+                <a:ea typeface="Meiryo UI" panose="020B0604030504040204" pitchFamily="34" charset="-128"/>
+              </a:defRPr>
+            </a:lvl3pPr>
+            <a:lvl4pPr>
+              <a:defRPr sz="1200">
+                <a:latin typeface="Meiryo UI" panose="020B0604030504040204" pitchFamily="34" charset="-128"/>
+                <a:ea typeface="Meiryo UI" panose="020B0604030504040204" pitchFamily="34" charset="-128"/>
+              </a:defRPr>
+            </a:lvl4pPr>
+            <a:lvl5pPr>
+              <a:defRPr sz="1200">
+                <a:latin typeface="Meiryo UI" panose="020B0604030504040204" pitchFamily="34" charset="-128"/>
+                <a:ea typeface="Meiryo UI" panose="020B0604030504040204" pitchFamily="34" charset="-128"/>
+              </a:defRPr>
+            </a:lvl5pPr>
+          </a:lstStyle>
+          <a:p>
+            <a:pPr lvl="0"/>
+            <a:r>
+              <a:rPr kumimoji="1" lang="ja-JP" altLang="en-US"/>
+              <a:t>マスター テキストの書式設定</a:t>
+            </a:r>
+          </a:p>
+          <a:p>
+            <a:pPr lvl="1"/>
+            <a:r>
+              <a:rPr kumimoji="1" lang="ja-JP" altLang="en-US"/>
+              <a:t>第 </a:t>
+            </a:r>
+            <a:r>
+              <a:rPr kumimoji="1" lang="en-US" altLang="ja-JP"/>
+              <a:t>2 </a:t>
+            </a:r>
+            <a:r>
+              <a:rPr kumimoji="1" lang="ja-JP" altLang="en-US"/>
+              <a:t>レベル</a:t>
+            </a:r>
+          </a:p>
+          <a:p>
+            <a:pPr lvl="2"/>
+            <a:r>
+              <a:rPr kumimoji="1" lang="ja-JP" altLang="en-US"/>
+              <a:t>第 </a:t>
+            </a:r>
+            <a:r>
+              <a:rPr kumimoji="1" lang="en-US" altLang="ja-JP"/>
+              <a:t>3 </a:t>
+            </a:r>
+            <a:r>
+              <a:rPr kumimoji="1" lang="ja-JP" altLang="en-US"/>
+              <a:t>レベル</a:t>
+            </a:r>
+          </a:p>
+          <a:p>
+            <a:pPr lvl="3"/>
+            <a:r>
+              <a:rPr kumimoji="1" lang="ja-JP" altLang="en-US"/>
+              <a:t>第 </a:t>
+            </a:r>
+            <a:r>
+              <a:rPr kumimoji="1" lang="en-US" altLang="ja-JP"/>
+              <a:t>4 </a:t>
+            </a:r>
+            <a:r>
+              <a:rPr kumimoji="1" lang="ja-JP" altLang="en-US"/>
+              <a:t>レベル</a:t>
+            </a:r>
+          </a:p>
+          <a:p>
+            <a:pPr lvl="4"/>
+            <a:r>
+              <a:rPr kumimoji="1" lang="ja-JP" altLang="en-US"/>
+              <a:t>第 </a:t>
+            </a:r>
+            <a:r>
+              <a:rPr kumimoji="1" lang="en-US" altLang="ja-JP"/>
+              <a:t>5 </a:t>
+            </a:r>
+            <a:r>
+              <a:rPr kumimoji="1" lang="ja-JP" altLang="en-US"/>
+              <a:t>レベル</a:t>
+            </a:r>
+          </a:p>
+        </p:txBody>
+      </p:sp>
+      <p:sp>
+        <p:nvSpPr>
+          <p:cNvPr id="6" name="スライド番号プレースホルダー 5">
+            <a:extLst>
+              <a:ext uri="{FF2B5EF4-FFF2-40B4-BE49-F238E27FC236}">
+                <a16:creationId xmlns:a16="http://schemas.microsoft.com/office/drawing/2014/main" id="{ED36DFD0-93B2-8751-F203-50EE02E97C4C}"/>
+              </a:ext>
+            </a:extLst>
+          </p:cNvPr>
+          <p:cNvSpPr>
+            <a:spLocks noGrp="1"/>
+          </p:cNvSpPr>
+          <p:nvPr>
+            <p:ph type="sldNum" sz="quarter" idx="12"/>
+          </p:nvPr>
+        </p:nvSpPr>
+        <p:spPr/>
+        <p:txBody>
+          <a:bodyPr/>
+          <a:lstStyle>
+            <a:lvl1pPr>
+              <a:defRPr>
+                <a:latin typeface="Meiryo UI" panose="020B0604030504040204" pitchFamily="34" charset="-128"/>
+                <a:ea typeface="Meiryo UI" panose="020B0604030504040204" pitchFamily="34" charset="-128"/>
+              </a:defRPr>
+            </a:lvl1pPr>
+          </a:lstStyle>
+          <a:p>
+            <a:fld id="{C9FB15DA-11C7-0141-B5F8-718388A4C1CD}" type="slidenum">
+              <a:rPr lang="ja-JP" altLang="en-US" smtClean="0"/>
+              <a:pPr/>
+              <a:t>‹#›</a:t>
+            </a:fld>
+            <a:endParaRPr lang="ja-JP" altLang="en-US"/>
+          </a:p>
+        </p:txBody>
+      </p:sp>
+      <p:sp>
+        <p:nvSpPr>
+          <p:cNvPr id="5" name="Fact Subtitle">
+            <a:extLst>
+              <a:ext uri="{FF2B5EF4-FFF2-40B4-BE49-F238E27FC236}">
+                <a16:creationId xmlns:a16="http://schemas.microsoft.com/office/drawing/2014/main" id="{BC739F27-A820-A358-F2A4-B0876CFE8CED}"/>
+              </a:ext>
+            </a:extLst>
+          </p:cNvPr>
+          <p:cNvSpPr>
+            <a:spLocks noGrp="1"/>
+          </p:cNvSpPr>
+          <p:nvPr>
+            <p:ph type="subTitle" idx="15" hasCustomPrompt="1"/>
+          </p:nvPr>
+        </p:nvSpPr>
+        <p:spPr>
+          <a:xfrm>
+            <a:off x="312420" y="0"/>
+            <a:ext cx="4694586" cy="320634"/>
+          </a:xfrm>
+        </p:spPr>
+        <p:txBody>
+          <a:bodyPr anchor="b">
+            <a:normAutofit/>
+          </a:bodyPr>
+          <a:lstStyle>
+            <a:lvl1pPr marL="0" indent="0" algn="l">
+              <a:buNone/>
+              <a:defRPr sz="1800">
+                <a:solidFill>
+                  <a:srgbClr val="767676"/>
+                </a:solidFill>
+              </a:defRPr>
+            </a:lvl1pPr>
+            <a:lvl2pPr marL="457200" indent="0" algn="ctr">
+              <a:buNone/>
+              <a:defRPr sz="2000"/>
+            </a:lvl2pPr>
+            <a:lvl3pPr marL="914400" indent="0" algn="ctr">
+              <a:buNone/>
+              <a:defRPr sz="1800"/>
+            </a:lvl3pPr>
+            <a:lvl4pPr marL="1371600" indent="0" algn="ctr">
+              <a:buNone/>
+              <a:defRPr sz="1600"/>
+            </a:lvl4pPr>
+            <a:lvl5pPr marL="1828800" indent="0" algn="ctr">
+              <a:buNone/>
+              <a:defRPr sz="1600"/>
+            </a:lvl5pPr>
+            <a:lvl6pPr marL="2286000" indent="0" algn="ctr">
+              <a:buNone/>
+              <a:defRPr sz="1600"/>
+            </a:lvl6pPr>
+            <a:lvl7pPr marL="2743200" indent="0" algn="ctr">
+              <a:buNone/>
+              <a:defRPr sz="1600"/>
+            </a:lvl7pPr>
+            <a:lvl8pPr marL="3200400" indent="0" algn="ctr">
+              <a:buNone/>
+              <a:defRPr sz="1600"/>
+            </a:lvl8pPr>
+            <a:lvl9pPr marL="3657600" indent="0" algn="ctr">
+              <a:buNone/>
+              <a:defRPr sz="1600"/>
+            </a:lvl9pPr>
+          </a:lstStyle>
+          <a:p>
+            <a:pPr lvl="0"/>
+            <a:r>
+              <a:rPr kumimoji="1" lang="ja-JP" altLang="en-US"/>
+              <a:t>サブタイトル</a:t>
+            </a:r>
+            <a:r>
+              <a:rPr kumimoji="1" lang="en-US" altLang="ja-JP" dirty="0"/>
+              <a:t> </a:t>
+            </a:r>
+            <a:r>
+              <a:rPr kumimoji="1" lang="ja-JP" altLang="en-US"/>
+              <a:t>の書式設定</a:t>
+            </a:r>
+          </a:p>
+        </p:txBody>
+      </p:sp>
+      <p:sp>
+        <p:nvSpPr>
+          <p:cNvPr id="4" name="Logo">
+            <a:extLst>
+              <a:ext uri="{FF2B5EF4-FFF2-40B4-BE49-F238E27FC236}">
+                <a16:creationId xmlns:a16="http://schemas.microsoft.com/office/drawing/2014/main" id="{C8B9E751-8D56-C809-58EB-50C7E7A35524}"/>
+              </a:ext>
+            </a:extLst>
+          </p:cNvPr>
+          <p:cNvSpPr>
+            <a:spLocks noGrp="1"/>
+          </p:cNvSpPr>
+          <p:nvPr>
+            <p:ph sz="quarter" idx="14" hasCustomPrompt="1"/>
+          </p:nvPr>
+        </p:nvSpPr>
+        <p:spPr>
+          <a:xfrm>
+            <a:off x="10965176" y="5262563"/>
+            <a:ext cx="914400" cy="914400"/>
+          </a:xfrm>
+        </p:spPr>
+        <p:txBody>
+          <a:bodyPr/>
+          <a:lstStyle>
+            <a:lvl1pPr marL="0" indent="0">
+              <a:buNone/>
+              <a:defRPr/>
+            </a:lvl1pPr>
+          </a:lstStyle>
+          <a:p>
+            <a:pPr lvl="0"/>
+            <a:r>
+              <a:rPr kumimoji="1" lang="en-US" altLang="ja-JP" dirty="0"/>
+              <a:t>logo</a:t>
+            </a:r>
+            <a:endParaRPr kumimoji="1" lang="ja-JP" altLang="en-US"/>
+          </a:p>
+        </p:txBody>
+      </p:sp>
+    </p:spTree>
+    <p:extLst>
+      <p:ext uri="{BB962C8B-B14F-4D97-AF65-F5344CB8AC3E}">
+        <p14:creationId xmlns:p14="http://schemas.microsoft.com/office/powerpoint/2010/main" val="3983333325"/>
+      </p:ext>
+    </p:extLst>
+  </p:cSld>
+  <p:clrMapOvr>
+    <a:masterClrMapping/>
+  </p:clrMapOvr>
+</p:sldLayout>
+</file>
+
 <file path=ppt/slideMasters/slideMaster1.xml><?xml version="1.0" encoding="utf-8"?>
 <p:sldMaster xmlns:a="http://schemas.openxmlformats.org/drawingml/2006/main" xmlns:r="http://schemas.openxmlformats.org/officeDocument/2006/relationships" xmlns:p="http://schemas.openxmlformats.org/presentationml/2006/main" preserve="1">
   <p:cSld>
@@ -3248,6 +4559,9 @@
     <p:sldLayoutId id="2147483653" r:id="rId4"/>
     <p:sldLayoutId id="2147483655" r:id="rId5"/>
     <p:sldLayoutId id="2147483654" r:id="rId6"/>
+    <p:sldLayoutId id="2147483656" r:id="rId8"/>
+    <p:sldLayoutId id="2147483657" r:id="rId9"/>
+    <p:sldLayoutId id="2147483658" r:id="rId10"/>
   </p:sldLayoutIdLst>
   <p:hf sldNum="0" hdr="0" dt="0"/>
   <p:txStyles>

</xml_diff>

<commit_message>
fix template page name
</commit_message>
<xml_diff>
--- a/samples/templates/templates.pptx
+++ b/samples/templates/templates.pptx
@@ -197,7 +197,7 @@
           <a:p>
             <a:fld id="{D83749C5-FFD9-114C-B10A-D0464B391B79}" type="datetimeFigureOut">
               <a:rPr kumimoji="1" lang="ja-JP" altLang="en-US" smtClean="0"/>
-              <a:t>2025/10/31</a:t>
+              <a:t>2025/11/10</a:t>
             </a:fld>
             <a:endParaRPr kumimoji="1" lang="ja-JP" altLang="en-US"/>
           </a:p>
@@ -8289,7 +8289,7 @@
 
 <file path=ppt/slideLayouts/slideLayout2.xml><?xml version="1.0" encoding="utf-8"?>
 <p:sldLayout xmlns:a="http://schemas.openxmlformats.org/drawingml/2006/main" xmlns:r="http://schemas.openxmlformats.org/officeDocument/2006/relationships" xmlns:p="http://schemas.openxmlformats.org/presentationml/2006/main" preserve="1" userDrawn="1">
-  <p:cSld name="Section Covor Left">
+  <p:cSld name="Section Cover Left">
     <p:spTree>
       <p:nvGrpSpPr>
         <p:cNvPr id="1" name=""/>
@@ -9723,7 +9723,7 @@
 
 <file path=ppt/slideLayouts/slideLayout22.xml><?xml version="1.0" encoding="utf-8"?>
 <p:sldLayout xmlns:a="http://schemas.openxmlformats.org/drawingml/2006/main" xmlns:r="http://schemas.openxmlformats.org/officeDocument/2006/relationships" xmlns:p="http://schemas.openxmlformats.org/presentationml/2006/main" preserve="1" userDrawn="1">
-  <p:cSld name="1_Two Flow">
+  <p:cSld name="Four Flow">
     <p:spTree>
       <p:nvGrpSpPr>
         <p:cNvPr id="1" name=""/>
@@ -10866,7 +10866,7 @@
 
 <file path=ppt/slideLayouts/slideLayout24.xml><?xml version="1.0" encoding="utf-8"?>
 <p:sldLayout xmlns:a="http://schemas.openxmlformats.org/drawingml/2006/main" xmlns:r="http://schemas.openxmlformats.org/officeDocument/2006/relationships" xmlns:p="http://schemas.openxmlformats.org/presentationml/2006/main" preserve="1" userDrawn="1">
-  <p:cSld name="Closin Covor">
+  <p:cSld name="Closing Cover">
     <p:spTree>
       <p:nvGrpSpPr>
         <p:cNvPr id="1" name=""/>
@@ -10936,7 +10936,7 @@
 
 <file path=ppt/slideLayouts/slideLayout3.xml><?xml version="1.0" encoding="utf-8"?>
 <p:sldLayout xmlns:a="http://schemas.openxmlformats.org/drawingml/2006/main" xmlns:r="http://schemas.openxmlformats.org/officeDocument/2006/relationships" xmlns:p="http://schemas.openxmlformats.org/presentationml/2006/main" preserve="1" userDrawn="1">
-  <p:cSld name="Section Covor Center">
+  <p:cSld name="Section Cover Center">
     <p:spTree>
       <p:nvGrpSpPr>
         <p:cNvPr id="1" name=""/>

</xml_diff>

<commit_message>
chore(samples): refresh templates artifact
</commit_message>
<xml_diff>
--- a/samples/templates/templates.pptx
+++ b/samples/templates/templates.pptx
@@ -197,7 +197,7 @@
           <a:p>
             <a:fld id="{D83749C5-FFD9-114C-B10A-D0464B391B79}" type="datetimeFigureOut">
               <a:rPr kumimoji="1" lang="ja-JP" altLang="en-US" smtClean="0"/>
-              <a:t>2025/10/31</a:t>
+              <a:t>2025/11/21</a:t>
             </a:fld>
             <a:endParaRPr kumimoji="1" lang="ja-JP" altLang="en-US"/>
           </a:p>
@@ -2465,6 +2465,91 @@
             <a:r>
               <a:rPr kumimoji="1" lang="ja-JP" altLang="en-US"/>
               <a:t>レベル</a:t>
+            </a:r>
+          </a:p>
+        </p:txBody>
+      </p:sp>
+      <p:sp>
+        <p:nvSpPr>
+          <p:cNvPr id="2" name="Sub Title">
+            <a:extLst>
+              <a:ext uri="{FF2B5EF4-FFF2-40B4-BE49-F238E27FC236}">
+                <a16:creationId xmlns:a16="http://schemas.microsoft.com/office/drawing/2014/main" id="{3D7F7988-9A88-847F-2952-A301484419F9}"/>
+              </a:ext>
+            </a:extLst>
+          </p:cNvPr>
+          <p:cNvSpPr>
+            <a:spLocks noGrp="1"/>
+          </p:cNvSpPr>
+          <p:nvPr>
+            <p:ph type="subTitle" idx="17" hasCustomPrompt="1"/>
+          </p:nvPr>
+        </p:nvSpPr>
+        <p:spPr>
+          <a:xfrm>
+            <a:off x="312420" y="0"/>
+            <a:ext cx="4694586" cy="320634"/>
+          </a:xfrm>
+        </p:spPr>
+        <p:txBody>
+          <a:bodyPr anchor="b">
+            <a:normAutofit/>
+          </a:bodyPr>
+          <a:lstStyle>
+            <a:lvl1pPr marL="0" indent="0" algn="l">
+              <a:buNone/>
+              <a:defRPr sz="1800">
+                <a:solidFill>
+                  <a:srgbClr val="767676"/>
+                </a:solidFill>
+              </a:defRPr>
+            </a:lvl1pPr>
+            <a:lvl2pPr marL="457200" indent="0" algn="ctr">
+              <a:buNone/>
+              <a:defRPr sz="2000"/>
+            </a:lvl2pPr>
+            <a:lvl3pPr marL="914400" indent="0" algn="ctr">
+              <a:buNone/>
+              <a:defRPr sz="1800"/>
+            </a:lvl3pPr>
+            <a:lvl4pPr marL="1371600" indent="0" algn="ctr">
+              <a:buNone/>
+              <a:defRPr sz="1600"/>
+            </a:lvl4pPr>
+            <a:lvl5pPr marL="1828800" indent="0" algn="ctr">
+              <a:buNone/>
+              <a:defRPr sz="1600"/>
+            </a:lvl5pPr>
+            <a:lvl6pPr marL="2286000" indent="0" algn="ctr">
+              <a:buNone/>
+              <a:defRPr sz="1600"/>
+            </a:lvl6pPr>
+            <a:lvl7pPr marL="2743200" indent="0" algn="ctr">
+              <a:buNone/>
+              <a:defRPr sz="1600"/>
+            </a:lvl7pPr>
+            <a:lvl8pPr marL="3200400" indent="0" algn="ctr">
+              <a:buNone/>
+              <a:defRPr sz="1600"/>
+            </a:lvl8pPr>
+            <a:lvl9pPr marL="3657600" indent="0" algn="ctr">
+              <a:buNone/>
+              <a:defRPr sz="1600"/>
+            </a:lvl9pPr>
+          </a:lstStyle>
+          <a:p>
+            <a:pPr lvl="0"/>
+            <a:r>
+              <a:rPr kumimoji="1" lang="ja-JP" altLang="en-US"/>
+              <a:t>サブタイトル</a:t>
+            </a:r>
+            <a:r>
+              <a:rPr kumimoji="1" lang="en-US" altLang="ja-JP" dirty="0"/>
+              <a:t> </a:t>
+            </a:r>
+            <a:r>
+              <a:rPr kumimoji="1" lang="ja-JP" altLang="en-US"/>
+              <a:t>の書式設定</a:t>
             </a:r>
           </a:p>
         </p:txBody>

</xml_diff>